<commit_message>
vault backup: 2026-09-19 19:58:06
</commit_message>
<xml_diff>
--- a/handover/calibration_dig_recheck_20260919.pptx
+++ b/handover/calibration_dig_recheck_20260919.pptx
@@ -5,7 +5,7 @@
     <p:sldMasterId id="2147483648" r:id="rId1"/>
   </p:sldMasterIdLst>
   <p:sldIdLst>
-    <p:sldId id="256" r:id="rId7"/>
+    <p:sldId id="256" r:id="rId2"/>
   </p:sldIdLst>
   <p:sldSz cx="9144000" cy="6858000" type="screen4x3"/>
   <p:notesSz cx="6858000" cy="9144000"/>
@@ -104,6 +104,22 @@
       </a:defRPr>
     </a:lvl9pPr>
   </p:defaultTextStyle>
+  <p:extLst>
+    <p:ext uri="{EFAFB233-063F-42B5-8137-9DF3F51BA10A}">
+      <p15:sldGuideLst xmlns:p15="http://schemas.microsoft.com/office/powerpoint/2012/main">
+        <p15:guide id="1" orient="horz" pos="2160">
+          <p15:clr>
+            <a:srgbClr val="A4A3A4"/>
+          </p15:clr>
+        </p15:guide>
+        <p15:guide id="2" pos="2880">
+          <p15:clr>
+            <a:srgbClr val="A4A3A4"/>
+          </p15:clr>
+        </p15:guide>
+      </p15:sldGuideLst>
+    </p:ext>
+  </p:extLst>
 </p:presentation>
 </file>
 
@@ -145,10 +161,9 @@
           <a:lstStyle/>
           <a:p>
             <a:r>
-              <a:rPr lang="en-US" smtClean="0"/>
+              <a:rPr lang="en-US"/>
               <a:t>Click to edit Master title style</a:t>
             </a:r>
-            <a:endParaRPr lang="en-US"/>
           </a:p>
         </p:txBody>
       </p:sp>
@@ -264,10 +279,9 @@
           </a:lstStyle>
           <a:p>
             <a:r>
-              <a:rPr lang="en-US" smtClean="0"/>
+              <a:rPr lang="en-US"/>
               <a:t>Click to edit Master subtitle style</a:t>
             </a:r>
-            <a:endParaRPr lang="en-US"/>
           </a:p>
         </p:txBody>
       </p:sp>
@@ -288,7 +302,7 @@
           <a:p>
             <a:fld id="{5BCAD085-E8A6-8845-BD4E-CB4CCA059FC4}" type="datetimeFigureOut">
               <a:rPr lang="en-US" smtClean="0"/>
-              <a:t>1/27/13</a:t>
+              <a:t>9/18/2026</a:t>
             </a:fld>
             <a:endParaRPr lang="en-US"/>
           </a:p>
@@ -382,10 +396,9 @@
           <a:lstStyle/>
           <a:p>
             <a:r>
-              <a:rPr lang="en-US" smtClean="0"/>
+              <a:rPr lang="en-US"/>
               <a:t>Click to edit Master title style</a:t>
             </a:r>
-            <a:endParaRPr lang="en-US"/>
           </a:p>
         </p:txBody>
       </p:sp>
@@ -406,38 +419,37 @@
           <a:p>
             <a:pPr lvl="0"/>
             <a:r>
-              <a:rPr lang="en-US" smtClean="0"/>
+              <a:rPr lang="en-US"/>
               <a:t>Click to edit Master text styles</a:t>
             </a:r>
           </a:p>
           <a:p>
             <a:pPr lvl="1"/>
             <a:r>
-              <a:rPr lang="en-US" smtClean="0"/>
+              <a:rPr lang="en-US"/>
               <a:t>Second level</a:t>
             </a:r>
           </a:p>
           <a:p>
             <a:pPr lvl="2"/>
             <a:r>
-              <a:rPr lang="en-US" smtClean="0"/>
+              <a:rPr lang="en-US"/>
               <a:t>Third level</a:t>
             </a:r>
           </a:p>
           <a:p>
             <a:pPr lvl="3"/>
             <a:r>
-              <a:rPr lang="en-US" smtClean="0"/>
+              <a:rPr lang="en-US"/>
               <a:t>Fourth level</a:t>
             </a:r>
           </a:p>
           <a:p>
             <a:pPr lvl="4"/>
             <a:r>
-              <a:rPr lang="en-US" smtClean="0"/>
+              <a:rPr lang="en-US"/>
               <a:t>Fifth level</a:t>
             </a:r>
-            <a:endParaRPr lang="en-US"/>
           </a:p>
         </p:txBody>
       </p:sp>
@@ -458,7 +470,7 @@
           <a:p>
             <a:fld id="{5BCAD085-E8A6-8845-BD4E-CB4CCA059FC4}" type="datetimeFigureOut">
               <a:rPr lang="en-US" smtClean="0"/>
-              <a:t>1/27/13</a:t>
+              <a:t>9/18/2026</a:t>
             </a:fld>
             <a:endParaRPr lang="en-US"/>
           </a:p>
@@ -557,10 +569,9 @@
           <a:lstStyle/>
           <a:p>
             <a:r>
-              <a:rPr lang="en-US" smtClean="0"/>
+              <a:rPr lang="en-US"/>
               <a:t>Click to edit Master title style</a:t>
             </a:r>
-            <a:endParaRPr lang="en-US"/>
           </a:p>
         </p:txBody>
       </p:sp>
@@ -586,38 +597,37 @@
           <a:p>
             <a:pPr lvl="0"/>
             <a:r>
-              <a:rPr lang="en-US" smtClean="0"/>
+              <a:rPr lang="en-US"/>
               <a:t>Click to edit Master text styles</a:t>
             </a:r>
           </a:p>
           <a:p>
             <a:pPr lvl="1"/>
             <a:r>
-              <a:rPr lang="en-US" smtClean="0"/>
+              <a:rPr lang="en-US"/>
               <a:t>Second level</a:t>
             </a:r>
           </a:p>
           <a:p>
             <a:pPr lvl="2"/>
             <a:r>
-              <a:rPr lang="en-US" smtClean="0"/>
+              <a:rPr lang="en-US"/>
               <a:t>Third level</a:t>
             </a:r>
           </a:p>
           <a:p>
             <a:pPr lvl="3"/>
             <a:r>
-              <a:rPr lang="en-US" smtClean="0"/>
+              <a:rPr lang="en-US"/>
               <a:t>Fourth level</a:t>
             </a:r>
           </a:p>
           <a:p>
             <a:pPr lvl="4"/>
             <a:r>
-              <a:rPr lang="en-US" smtClean="0"/>
+              <a:rPr lang="en-US"/>
               <a:t>Fifth level</a:t>
             </a:r>
-            <a:endParaRPr lang="en-US"/>
           </a:p>
         </p:txBody>
       </p:sp>
@@ -638,7 +648,7 @@
           <a:p>
             <a:fld id="{5BCAD085-E8A6-8845-BD4E-CB4CCA059FC4}" type="datetimeFigureOut">
               <a:rPr lang="en-US" smtClean="0"/>
-              <a:t>1/27/13</a:t>
+              <a:t>9/18/2026</a:t>
             </a:fld>
             <a:endParaRPr lang="en-US"/>
           </a:p>
@@ -732,10 +742,9 @@
           <a:lstStyle/>
           <a:p>
             <a:r>
-              <a:rPr lang="en-US" smtClean="0"/>
+              <a:rPr lang="en-US"/>
               <a:t>Click to edit Master title style</a:t>
             </a:r>
-            <a:endParaRPr lang="en-US"/>
           </a:p>
         </p:txBody>
       </p:sp>
@@ -756,38 +765,37 @@
           <a:p>
             <a:pPr lvl="0"/>
             <a:r>
-              <a:rPr lang="en-US" smtClean="0"/>
+              <a:rPr lang="en-US"/>
               <a:t>Click to edit Master text styles</a:t>
             </a:r>
           </a:p>
           <a:p>
             <a:pPr lvl="1"/>
             <a:r>
-              <a:rPr lang="en-US" smtClean="0"/>
+              <a:rPr lang="en-US"/>
               <a:t>Second level</a:t>
             </a:r>
           </a:p>
           <a:p>
             <a:pPr lvl="2"/>
             <a:r>
-              <a:rPr lang="en-US" smtClean="0"/>
+              <a:rPr lang="en-US"/>
               <a:t>Third level</a:t>
             </a:r>
           </a:p>
           <a:p>
             <a:pPr lvl="3"/>
             <a:r>
-              <a:rPr lang="en-US" smtClean="0"/>
+              <a:rPr lang="en-US"/>
               <a:t>Fourth level</a:t>
             </a:r>
           </a:p>
           <a:p>
             <a:pPr lvl="4"/>
             <a:r>
-              <a:rPr lang="en-US" smtClean="0"/>
+              <a:rPr lang="en-US"/>
               <a:t>Fifth level</a:t>
             </a:r>
-            <a:endParaRPr lang="en-US"/>
           </a:p>
         </p:txBody>
       </p:sp>
@@ -808,7 +816,7 @@
           <a:p>
             <a:fld id="{5BCAD085-E8A6-8845-BD4E-CB4CCA059FC4}" type="datetimeFigureOut">
               <a:rPr lang="en-US" smtClean="0"/>
-              <a:t>1/27/13</a:t>
+              <a:t>9/18/2026</a:t>
             </a:fld>
             <a:endParaRPr lang="en-US"/>
           </a:p>
@@ -911,10 +919,9 @@
           </a:lstStyle>
           <a:p>
             <a:r>
-              <a:rPr lang="en-US" smtClean="0"/>
+              <a:rPr lang="en-US"/>
               <a:t>Click to edit Master title style</a:t>
             </a:r>
-            <a:endParaRPr lang="en-US"/>
           </a:p>
         </p:txBody>
       </p:sp>
@@ -1031,7 +1038,7 @@
           <a:p>
             <a:pPr lvl="0"/>
             <a:r>
-              <a:rPr lang="en-US" smtClean="0"/>
+              <a:rPr lang="en-US"/>
               <a:t>Click to edit Master text styles</a:t>
             </a:r>
           </a:p>
@@ -1054,7 +1061,7 @@
           <a:p>
             <a:fld id="{5BCAD085-E8A6-8845-BD4E-CB4CCA059FC4}" type="datetimeFigureOut">
               <a:rPr lang="en-US" smtClean="0"/>
-              <a:t>1/27/13</a:t>
+              <a:t>9/18/2026</a:t>
             </a:fld>
             <a:endParaRPr lang="en-US"/>
           </a:p>
@@ -1148,10 +1155,9 @@
           <a:lstStyle/>
           <a:p>
             <a:r>
-              <a:rPr lang="en-US" smtClean="0"/>
+              <a:rPr lang="en-US"/>
               <a:t>Click to edit Master title style</a:t>
             </a:r>
-            <a:endParaRPr lang="en-US"/>
           </a:p>
         </p:txBody>
       </p:sp>
@@ -1205,38 +1211,37 @@
           <a:p>
             <a:pPr lvl="0"/>
             <a:r>
-              <a:rPr lang="en-US" smtClean="0"/>
+              <a:rPr lang="en-US"/>
               <a:t>Click to edit Master text styles</a:t>
             </a:r>
           </a:p>
           <a:p>
             <a:pPr lvl="1"/>
             <a:r>
-              <a:rPr lang="en-US" smtClean="0"/>
+              <a:rPr lang="en-US"/>
               <a:t>Second level</a:t>
             </a:r>
           </a:p>
           <a:p>
             <a:pPr lvl="2"/>
             <a:r>
-              <a:rPr lang="en-US" smtClean="0"/>
+              <a:rPr lang="en-US"/>
               <a:t>Third level</a:t>
             </a:r>
           </a:p>
           <a:p>
             <a:pPr lvl="3"/>
             <a:r>
-              <a:rPr lang="en-US" smtClean="0"/>
+              <a:rPr lang="en-US"/>
               <a:t>Fourth level</a:t>
             </a:r>
           </a:p>
           <a:p>
             <a:pPr lvl="4"/>
             <a:r>
-              <a:rPr lang="en-US" smtClean="0"/>
+              <a:rPr lang="en-US"/>
               <a:t>Fifth level</a:t>
             </a:r>
-            <a:endParaRPr lang="en-US"/>
           </a:p>
         </p:txBody>
       </p:sp>
@@ -1290,38 +1295,37 @@
           <a:p>
             <a:pPr lvl="0"/>
             <a:r>
-              <a:rPr lang="en-US" smtClean="0"/>
+              <a:rPr lang="en-US"/>
               <a:t>Click to edit Master text styles</a:t>
             </a:r>
           </a:p>
           <a:p>
             <a:pPr lvl="1"/>
             <a:r>
-              <a:rPr lang="en-US" smtClean="0"/>
+              <a:rPr lang="en-US"/>
               <a:t>Second level</a:t>
             </a:r>
           </a:p>
           <a:p>
             <a:pPr lvl="2"/>
             <a:r>
-              <a:rPr lang="en-US" smtClean="0"/>
+              <a:rPr lang="en-US"/>
               <a:t>Third level</a:t>
             </a:r>
           </a:p>
           <a:p>
             <a:pPr lvl="3"/>
             <a:r>
-              <a:rPr lang="en-US" smtClean="0"/>
+              <a:rPr lang="en-US"/>
               <a:t>Fourth level</a:t>
             </a:r>
           </a:p>
           <a:p>
             <a:pPr lvl="4"/>
             <a:r>
-              <a:rPr lang="en-US" smtClean="0"/>
+              <a:rPr lang="en-US"/>
               <a:t>Fifth level</a:t>
             </a:r>
-            <a:endParaRPr lang="en-US"/>
           </a:p>
         </p:txBody>
       </p:sp>
@@ -1342,7 +1346,7 @@
           <a:p>
             <a:fld id="{5BCAD085-E8A6-8845-BD4E-CB4CCA059FC4}" type="datetimeFigureOut">
               <a:rPr lang="en-US" smtClean="0"/>
-              <a:t>1/27/13</a:t>
+              <a:t>9/18/2026</a:t>
             </a:fld>
             <a:endParaRPr lang="en-US"/>
           </a:p>
@@ -1440,10 +1444,9 @@
           </a:lstStyle>
           <a:p>
             <a:r>
-              <a:rPr lang="en-US" smtClean="0"/>
+              <a:rPr lang="en-US"/>
               <a:t>Click to edit Master title style</a:t>
             </a:r>
-            <a:endParaRPr lang="en-US"/>
           </a:p>
         </p:txBody>
       </p:sp>
@@ -1506,7 +1509,7 @@
           <a:p>
             <a:pPr lvl="0"/>
             <a:r>
-              <a:rPr lang="en-US" smtClean="0"/>
+              <a:rPr lang="en-US"/>
               <a:t>Click to edit Master text styles</a:t>
             </a:r>
           </a:p>
@@ -1562,38 +1565,37 @@
           <a:p>
             <a:pPr lvl="0"/>
             <a:r>
-              <a:rPr lang="en-US" smtClean="0"/>
+              <a:rPr lang="en-US"/>
               <a:t>Click to edit Master text styles</a:t>
             </a:r>
           </a:p>
           <a:p>
             <a:pPr lvl="1"/>
             <a:r>
-              <a:rPr lang="en-US" smtClean="0"/>
+              <a:rPr lang="en-US"/>
               <a:t>Second level</a:t>
             </a:r>
           </a:p>
           <a:p>
             <a:pPr lvl="2"/>
             <a:r>
-              <a:rPr lang="en-US" smtClean="0"/>
+              <a:rPr lang="en-US"/>
               <a:t>Third level</a:t>
             </a:r>
           </a:p>
           <a:p>
             <a:pPr lvl="3"/>
             <a:r>
-              <a:rPr lang="en-US" smtClean="0"/>
+              <a:rPr lang="en-US"/>
               <a:t>Fourth level</a:t>
             </a:r>
           </a:p>
           <a:p>
             <a:pPr lvl="4"/>
             <a:r>
-              <a:rPr lang="en-US" smtClean="0"/>
+              <a:rPr lang="en-US"/>
               <a:t>Fifth level</a:t>
             </a:r>
-            <a:endParaRPr lang="en-US"/>
           </a:p>
         </p:txBody>
       </p:sp>
@@ -1656,7 +1658,7 @@
           <a:p>
             <a:pPr lvl="0"/>
             <a:r>
-              <a:rPr lang="en-US" smtClean="0"/>
+              <a:rPr lang="en-US"/>
               <a:t>Click to edit Master text styles</a:t>
             </a:r>
           </a:p>
@@ -1712,38 +1714,37 @@
           <a:p>
             <a:pPr lvl="0"/>
             <a:r>
-              <a:rPr lang="en-US" smtClean="0"/>
+              <a:rPr lang="en-US"/>
               <a:t>Click to edit Master text styles</a:t>
             </a:r>
           </a:p>
           <a:p>
             <a:pPr lvl="1"/>
             <a:r>
-              <a:rPr lang="en-US" smtClean="0"/>
+              <a:rPr lang="en-US"/>
               <a:t>Second level</a:t>
             </a:r>
           </a:p>
           <a:p>
             <a:pPr lvl="2"/>
             <a:r>
-              <a:rPr lang="en-US" smtClean="0"/>
+              <a:rPr lang="en-US"/>
               <a:t>Third level</a:t>
             </a:r>
           </a:p>
           <a:p>
             <a:pPr lvl="3"/>
             <a:r>
-              <a:rPr lang="en-US" smtClean="0"/>
+              <a:rPr lang="en-US"/>
               <a:t>Fourth level</a:t>
             </a:r>
           </a:p>
           <a:p>
             <a:pPr lvl="4"/>
             <a:r>
-              <a:rPr lang="en-US" smtClean="0"/>
+              <a:rPr lang="en-US"/>
               <a:t>Fifth level</a:t>
             </a:r>
-            <a:endParaRPr lang="en-US"/>
           </a:p>
         </p:txBody>
       </p:sp>
@@ -1764,7 +1765,7 @@
           <a:p>
             <a:fld id="{5BCAD085-E8A6-8845-BD4E-CB4CCA059FC4}" type="datetimeFigureOut">
               <a:rPr lang="en-US" smtClean="0"/>
-              <a:t>1/27/13</a:t>
+              <a:t>9/18/2026</a:t>
             </a:fld>
             <a:endParaRPr lang="en-US"/>
           </a:p>
@@ -1858,10 +1859,9 @@
           <a:lstStyle/>
           <a:p>
             <a:r>
-              <a:rPr lang="en-US" smtClean="0"/>
+              <a:rPr lang="en-US"/>
               <a:t>Click to edit Master title style</a:t>
             </a:r>
-            <a:endParaRPr lang="en-US"/>
           </a:p>
         </p:txBody>
       </p:sp>
@@ -1882,7 +1882,7 @@
           <a:p>
             <a:fld id="{5BCAD085-E8A6-8845-BD4E-CB4CCA059FC4}" type="datetimeFigureOut">
               <a:rPr lang="en-US" smtClean="0"/>
-              <a:t>1/27/13</a:t>
+              <a:t>9/18/2026</a:t>
             </a:fld>
             <a:endParaRPr lang="en-US"/>
           </a:p>
@@ -1977,7 +1977,7 @@
           <a:p>
             <a:fld id="{5BCAD085-E8A6-8845-BD4E-CB4CCA059FC4}" type="datetimeFigureOut">
               <a:rPr lang="en-US" smtClean="0"/>
-              <a:t>1/27/13</a:t>
+              <a:t>9/18/2026</a:t>
             </a:fld>
             <a:endParaRPr lang="en-US"/>
           </a:p>
@@ -2080,10 +2080,9 @@
           </a:lstStyle>
           <a:p>
             <a:r>
-              <a:rPr lang="en-US" smtClean="0"/>
+              <a:rPr lang="en-US"/>
               <a:t>Click to edit Master title style</a:t>
             </a:r>
-            <a:endParaRPr lang="en-US"/>
           </a:p>
         </p:txBody>
       </p:sp>
@@ -2137,38 +2136,37 @@
           <a:p>
             <a:pPr lvl="0"/>
             <a:r>
-              <a:rPr lang="en-US" smtClean="0"/>
+              <a:rPr lang="en-US"/>
               <a:t>Click to edit Master text styles</a:t>
             </a:r>
           </a:p>
           <a:p>
             <a:pPr lvl="1"/>
             <a:r>
-              <a:rPr lang="en-US" smtClean="0"/>
+              <a:rPr lang="en-US"/>
               <a:t>Second level</a:t>
             </a:r>
           </a:p>
           <a:p>
             <a:pPr lvl="2"/>
             <a:r>
-              <a:rPr lang="en-US" smtClean="0"/>
+              <a:rPr lang="en-US"/>
               <a:t>Third level</a:t>
             </a:r>
           </a:p>
           <a:p>
             <a:pPr lvl="3"/>
             <a:r>
-              <a:rPr lang="en-US" smtClean="0"/>
+              <a:rPr lang="en-US"/>
               <a:t>Fourth level</a:t>
             </a:r>
           </a:p>
           <a:p>
             <a:pPr lvl="4"/>
             <a:r>
-              <a:rPr lang="en-US" smtClean="0"/>
+              <a:rPr lang="en-US"/>
               <a:t>Fifth level</a:t>
             </a:r>
-            <a:endParaRPr lang="en-US"/>
           </a:p>
         </p:txBody>
       </p:sp>
@@ -2231,7 +2229,7 @@
           <a:p>
             <a:pPr lvl="0"/>
             <a:r>
-              <a:rPr lang="en-US" smtClean="0"/>
+              <a:rPr lang="en-US"/>
               <a:t>Click to edit Master text styles</a:t>
             </a:r>
           </a:p>
@@ -2254,7 +2252,7 @@
           <a:p>
             <a:fld id="{5BCAD085-E8A6-8845-BD4E-CB4CCA059FC4}" type="datetimeFigureOut">
               <a:rPr lang="en-US" smtClean="0"/>
-              <a:t>1/27/13</a:t>
+              <a:t>9/18/2026</a:t>
             </a:fld>
             <a:endParaRPr lang="en-US"/>
           </a:p>
@@ -2357,10 +2355,9 @@
           </a:lstStyle>
           <a:p>
             <a:r>
-              <a:rPr lang="en-US" smtClean="0"/>
+              <a:rPr lang="en-US"/>
               <a:t>Click to edit Master title style</a:t>
             </a:r>
-            <a:endParaRPr lang="en-US"/>
           </a:p>
         </p:txBody>
       </p:sp>
@@ -2484,7 +2481,7 @@
           <a:p>
             <a:pPr lvl="0"/>
             <a:r>
-              <a:rPr lang="en-US" smtClean="0"/>
+              <a:rPr lang="en-US"/>
               <a:t>Click to edit Master text styles</a:t>
             </a:r>
           </a:p>
@@ -2507,7 +2504,7 @@
           <a:p>
             <a:fld id="{5BCAD085-E8A6-8845-BD4E-CB4CCA059FC4}" type="datetimeFigureOut">
               <a:rPr lang="en-US" smtClean="0"/>
-              <a:t>1/27/13</a:t>
+              <a:t>9/18/2026</a:t>
             </a:fld>
             <a:endParaRPr lang="en-US"/>
           </a:p>
@@ -2616,10 +2613,9 @@
           <a:lstStyle/>
           <a:p>
             <a:r>
-              <a:rPr lang="en-US" smtClean="0"/>
+              <a:rPr lang="en-US"/>
               <a:t>Click to edit Master title style</a:t>
             </a:r>
-            <a:endParaRPr lang="en-US"/>
           </a:p>
         </p:txBody>
       </p:sp>
@@ -2650,38 +2646,37 @@
           <a:p>
             <a:pPr lvl="0"/>
             <a:r>
-              <a:rPr lang="en-US" smtClean="0"/>
+              <a:rPr lang="en-US"/>
               <a:t>Click to edit Master text styles</a:t>
             </a:r>
           </a:p>
           <a:p>
             <a:pPr lvl="1"/>
             <a:r>
-              <a:rPr lang="en-US" smtClean="0"/>
+              <a:rPr lang="en-US"/>
               <a:t>Second level</a:t>
             </a:r>
           </a:p>
           <a:p>
             <a:pPr lvl="2"/>
             <a:r>
-              <a:rPr lang="en-US" smtClean="0"/>
+              <a:rPr lang="en-US"/>
               <a:t>Third level</a:t>
             </a:r>
           </a:p>
           <a:p>
             <a:pPr lvl="3"/>
             <a:r>
-              <a:rPr lang="en-US" smtClean="0"/>
+              <a:rPr lang="en-US"/>
               <a:t>Fourth level</a:t>
             </a:r>
           </a:p>
           <a:p>
             <a:pPr lvl="4"/>
             <a:r>
-              <a:rPr lang="en-US" smtClean="0"/>
+              <a:rPr lang="en-US"/>
               <a:t>Fifth level</a:t>
             </a:r>
-            <a:endParaRPr lang="en-US"/>
           </a:p>
         </p:txBody>
       </p:sp>
@@ -2720,7 +2715,7 @@
           <a:p>
             <a:fld id="{5BCAD085-E8A6-8845-BD4E-CB4CCA059FC4}" type="datetimeFigureOut">
               <a:rPr lang="en-US" smtClean="0"/>
-              <a:t>1/27/13</a:t>
+              <a:t>9/18/2026</a:t>
             </a:fld>
             <a:endParaRPr lang="en-US"/>
           </a:p>
@@ -3079,7 +3074,7 @@
 </file>
 
 <file path=ppt/slides/slide1.xml><?xml version="1.0" encoding="utf-8"?>
-<p:sld xmlns:a="http://schemas.openxmlformats.org/drawingml/2006/main" xmlns:p="http://schemas.openxmlformats.org/presentationml/2006/main" xmlns:r="http://schemas.openxmlformats.org/officeDocument/2006/relationships">
+<p:sld xmlns:a="http://schemas.openxmlformats.org/drawingml/2006/main" xmlns:r="http://schemas.openxmlformats.org/officeDocument/2006/relationships" xmlns:p="http://schemas.openxmlformats.org/presentationml/2006/main">
   <p:cSld>
     <p:spTree>
       <p:nvGrpSpPr>
@@ -3087,7 +3082,14 @@
         <p:cNvGrpSpPr/>
         <p:nvPr/>
       </p:nvGrpSpPr>
-      <p:grpSpPr/>
+      <p:grpSpPr>
+        <a:xfrm>
+          <a:off x="0" y="0"/>
+          <a:ext cx="0" cy="0"/>
+          <a:chOff x="0" y="0"/>
+          <a:chExt cx="0" cy="0"/>
+        </a:xfrm>
+      </p:grpSpPr>
       <p:sp>
         <p:nvSpPr>
           <p:cNvPr id="2" name="TextBox 1"/>
@@ -3105,7 +3107,7 @@
           <a:noFill/>
         </p:spPr>
         <p:txBody>
-          <a:bodyPr wrap="none" lIns="0" rIns="0" tIns="0" bIns="0">
+          <a:bodyPr wrap="none" lIns="0" tIns="0" rIns="0" bIns="0">
             <a:spAutoFit/>
           </a:bodyPr>
           <a:lstStyle/>
@@ -3139,7 +3141,7 @@
           <a:noFill/>
         </p:spPr>
         <p:txBody>
-          <a:bodyPr wrap="none" lIns="0" rIns="0" tIns="0" bIns="0">
+          <a:bodyPr wrap="none" lIns="0" tIns="0" rIns="0" bIns="0">
             <a:spAutoFit/>
           </a:bodyPr>
           <a:lstStyle/>
@@ -3173,7 +3175,7 @@
           <a:noFill/>
         </p:spPr>
         <p:txBody>
-          <a:bodyPr wrap="none" lIns="0" rIns="0" tIns="0" bIns="0">
+          <a:bodyPr wrap="none" lIns="0" tIns="0" rIns="0" bIns="0">
             <a:spAutoFit/>
           </a:bodyPr>
           <a:lstStyle/>
@@ -3207,7 +3209,7 @@
           <a:noFill/>
         </p:spPr>
         <p:txBody>
-          <a:bodyPr wrap="none" lIns="0" rIns="0" tIns="0" bIns="0">
+          <a:bodyPr wrap="none" lIns="0" tIns="0" rIns="0" bIns="0">
             <a:spAutoFit/>
           </a:bodyPr>
           <a:lstStyle/>
@@ -3241,7 +3243,7 @@
           <a:noFill/>
         </p:spPr>
         <p:txBody>
-          <a:bodyPr wrap="none" lIns="0" rIns="0" tIns="0" bIns="0">
+          <a:bodyPr wrap="none" lIns="0" tIns="0" rIns="0" bIns="0">
             <a:spAutoFit/>
           </a:bodyPr>
           <a:lstStyle/>
@@ -3267,7 +3269,7 @@
         <p:spPr>
           <a:xfrm>
             <a:off x="2011680" y="1874519"/>
-            <a:ext cx="3657600" cy="457200"/>
+            <a:ext cx="1255395" cy="215444"/>
           </a:xfrm>
           <a:prstGeom prst="rect">
             <a:avLst/>
@@ -3275,13 +3277,13 @@
           <a:noFill/>
         </p:spPr>
         <p:txBody>
-          <a:bodyPr wrap="none" lIns="0" rIns="0" tIns="0" bIns="0">
+          <a:bodyPr wrap="square" lIns="0" tIns="0" rIns="0" bIns="0">
             <a:spAutoFit/>
           </a:bodyPr>
           <a:lstStyle/>
           <a:p>
             <a:r>
-              <a:rPr sz="1400" b="1">
+              <a:rPr sz="1400" b="1" dirty="0">
                 <a:solidFill>
                   <a:srgbClr val="000000"/>
                 </a:solidFill>
@@ -3301,7 +3303,7 @@
         <p:spPr>
           <a:xfrm>
             <a:off x="6035040" y="1920239"/>
-            <a:ext cx="2743200" cy="365760"/>
+            <a:ext cx="1096454" cy="200055"/>
           </a:xfrm>
           <a:prstGeom prst="rect">
             <a:avLst/>
@@ -3309,20 +3311,35 @@
           <a:noFill/>
         </p:spPr>
         <p:txBody>
-          <a:bodyPr wrap="none" lIns="0" rIns="0" tIns="0" bIns="0">
+          <a:bodyPr wrap="none" lIns="0" tIns="0" rIns="0" bIns="0">
             <a:spAutoFit/>
           </a:bodyPr>
           <a:lstStyle/>
           <a:p>
             <a:r>
-              <a:rPr sz="1300" b="0">
+              <a:rPr sz="1300" b="0" dirty="0">
                 <a:solidFill>
                   <a:srgbClr val="646464"/>
                 </a:solidFill>
                 <a:latin typeface="Meiryo"/>
               </a:rPr>
-              <a:t>幅(cm)：______________</a:t>
-            </a:r>
+              <a:t>幅(cm)：</a:t>
+            </a:r>
+            <a:r>
+              <a:rPr lang="en-US" altLang="ja-JP" sz="1300" b="0" dirty="0">
+                <a:solidFill>
+                  <a:srgbClr val="646464"/>
+                </a:solidFill>
+                <a:latin typeface="Meiryo"/>
+              </a:rPr>
+              <a:t>3.49</a:t>
+            </a:r>
+            <a:endParaRPr sz="1300" b="0" dirty="0">
+              <a:solidFill>
+                <a:srgbClr val="646464"/>
+              </a:solidFill>
+              <a:latin typeface="Meiryo"/>
+            </a:endParaRPr>
           </a:p>
         </p:txBody>
       </p:sp>
@@ -3343,7 +3360,7 @@
           <a:noFill/>
         </p:spPr>
         <p:txBody>
-          <a:bodyPr wrap="none" lIns="0" rIns="0" tIns="0" bIns="0">
+          <a:bodyPr wrap="none" lIns="0" tIns="0" rIns="0" bIns="0">
             <a:spAutoFit/>
           </a:bodyPr>
           <a:lstStyle/>
@@ -3369,7 +3386,7 @@
         <p:spPr>
           <a:xfrm>
             <a:off x="2011680" y="2514600"/>
-            <a:ext cx="3657600" cy="457200"/>
+            <a:ext cx="1255395" cy="215444"/>
           </a:xfrm>
           <a:prstGeom prst="rect">
             <a:avLst/>
@@ -3377,13 +3394,13 @@
           <a:noFill/>
         </p:spPr>
         <p:txBody>
-          <a:bodyPr wrap="none" lIns="0" rIns="0" tIns="0" bIns="0">
+          <a:bodyPr wrap="square" lIns="0" tIns="0" rIns="0" bIns="0">
             <a:spAutoFit/>
           </a:bodyPr>
           <a:lstStyle/>
           <a:p>
             <a:r>
-              <a:rPr sz="1400" b="1">
+              <a:rPr sz="1400" b="1" dirty="0">
                 <a:solidFill>
                   <a:srgbClr val="000000"/>
                 </a:solidFill>
@@ -3403,7 +3420,7 @@
         <p:spPr>
           <a:xfrm>
             <a:off x="6035040" y="2560320"/>
-            <a:ext cx="2743200" cy="365760"/>
+            <a:ext cx="1096454" cy="200055"/>
           </a:xfrm>
           <a:prstGeom prst="rect">
             <a:avLst/>
@@ -3411,20 +3428,35 @@
           <a:noFill/>
         </p:spPr>
         <p:txBody>
-          <a:bodyPr wrap="none" lIns="0" rIns="0" tIns="0" bIns="0">
+          <a:bodyPr wrap="none" lIns="0" tIns="0" rIns="0" bIns="0">
             <a:spAutoFit/>
           </a:bodyPr>
           <a:lstStyle/>
           <a:p>
             <a:r>
-              <a:rPr sz="1300" b="0">
+              <a:rPr sz="1300" b="0" dirty="0">
                 <a:solidFill>
                   <a:srgbClr val="646464"/>
                 </a:solidFill>
                 <a:latin typeface="Meiryo"/>
               </a:rPr>
-              <a:t>幅(cm)：______________</a:t>
-            </a:r>
+              <a:t>幅(cm)：</a:t>
+            </a:r>
+            <a:r>
+              <a:rPr lang="en-US" altLang="ja-JP" sz="1300" b="0" dirty="0">
+                <a:solidFill>
+                  <a:srgbClr val="646464"/>
+                </a:solidFill>
+                <a:latin typeface="Meiryo"/>
+              </a:rPr>
+              <a:t>3.49</a:t>
+            </a:r>
+            <a:endParaRPr sz="1300" b="0" dirty="0">
+              <a:solidFill>
+                <a:srgbClr val="646464"/>
+              </a:solidFill>
+              <a:latin typeface="Meiryo"/>
+            </a:endParaRPr>
           </a:p>
         </p:txBody>
       </p:sp>
@@ -3445,7 +3477,7 @@
           <a:noFill/>
         </p:spPr>
         <p:txBody>
-          <a:bodyPr wrap="none" lIns="0" rIns="0" tIns="0" bIns="0">
+          <a:bodyPr wrap="none" lIns="0" tIns="0" rIns="0" bIns="0">
             <a:spAutoFit/>
           </a:bodyPr>
           <a:lstStyle/>
@@ -3479,7 +3511,7 @@
           <a:noFill/>
         </p:spPr>
         <p:txBody>
-          <a:bodyPr wrap="none" lIns="0" rIns="0" tIns="0" bIns="0">
+          <a:bodyPr wrap="none" lIns="0" tIns="0" rIns="0" bIns="0">
             <a:spAutoFit/>
           </a:bodyPr>
           <a:lstStyle/>
@@ -3513,7 +3545,7 @@
           <a:noFill/>
         </p:spPr>
         <p:txBody>
-          <a:bodyPr wrap="none" lIns="0" rIns="0" tIns="0" bIns="0">
+          <a:bodyPr wrap="none" lIns="0" tIns="0" rIns="0" bIns="0">
             <a:spAutoFit/>
           </a:bodyPr>
           <a:lstStyle/>
@@ -3547,7 +3579,7 @@
           <a:noFill/>
         </p:spPr>
         <p:txBody>
-          <a:bodyPr wrap="none" lIns="0" rIns="0" tIns="0" bIns="0">
+          <a:bodyPr wrap="none" lIns="0" tIns="0" rIns="0" bIns="0">
             <a:spAutoFit/>
           </a:bodyPr>
           <a:lstStyle/>
@@ -3581,7 +3613,7 @@
           <a:noFill/>
         </p:spPr>
         <p:txBody>
-          <a:bodyPr wrap="none" lIns="0" rIns="0" tIns="0" bIns="0">
+          <a:bodyPr wrap="none" lIns="0" tIns="0" rIns="0" bIns="0">
             <a:spAutoFit/>
           </a:bodyPr>
           <a:lstStyle/>

</xml_diff>